<commit_message>
Add Lessons Learned slide to LSSBB deck; fix pre-existing overflow
- New slide ("Lessons Learned · Running the Engagement") inserted
  before the closing "My Role & Skills" slide, matching the deck's
  existing card layout/palette. Content is grounded in facts already
  stated elsewhere in the deck plus generic PM takeaways, not invented
  specifics about the real engagement.
- Fixed an unrelated, pre-existing text overflow on the closing slide
  where the last "My Contributions" bullet collided with the footer
  bar (reduced bullet font size slightly and gave the card a bit more
  height).

Co-Authored-By: Claude Sonnet 5 <noreply@anthropic.com>
</commit_message>
<xml_diff>
--- a/LSSBB_Portfolio_Lewandowski.pptx
+++ b/LSSBB_Portfolio_Lewandowski.pptx
@@ -15,6 +15,7 @@
     <p:sldId id="263" r:id="rId9"/>
     <p:sldId id="264" r:id="rId10"/>
     <p:sldId id="265" r:id="rId11"/>
+    <p:sldId id="267" r:id="rId18"/>
     <p:sldId id="266" r:id="rId12"/>
   </p:sldIdLst>
   <p:notesMasterIdLst>
@@ -3247,7 +3248,7 @@
         <p:spPr>
           <a:xfrm>
             <a:off x="502920" y="2011680"/>
-            <a:ext cx="4114800" cy="2377440"/>
+            <a:ext cx="4114800" cy="2468880"/>
           </a:xfrm>
           <a:prstGeom prst="rect">
             <a:avLst/>
@@ -3311,7 +3312,7 @@
         <p:spPr>
           <a:xfrm>
             <a:off x="640080" y="2450592"/>
-            <a:ext cx="3840480" cy="1828800"/>
+            <a:ext cx="3840480" cy="1966056"/>
           </a:xfrm>
           <a:prstGeom prst="rect">
             <a:avLst/>
@@ -3331,7 +3332,7 @@
               <a:buChar char="•"/>
             </a:pPr>
             <a:r>
-              <a:rPr lang="en-US" sz="1100" dirty="0">
+              <a:rPr lang="en-US" sz="1000" dirty="0">
                 <a:solidFill>
                   <a:srgbClr val="D0D8F0"/>
                 </a:solidFill>
@@ -3352,7 +3353,7 @@
               <a:buChar char="•"/>
             </a:pPr>
             <a:r>
-              <a:rPr lang="en-US" sz="1100" dirty="0">
+              <a:rPr lang="en-US" sz="1000" dirty="0">
                 <a:solidFill>
                   <a:srgbClr val="D0D8F0"/>
                 </a:solidFill>
@@ -3373,7 +3374,7 @@
               <a:buChar char="•"/>
             </a:pPr>
             <a:r>
-              <a:rPr lang="en-US" sz="1100" dirty="0">
+              <a:rPr lang="en-US" sz="1000" dirty="0">
                 <a:solidFill>
                   <a:srgbClr val="D0D8F0"/>
                 </a:solidFill>
@@ -3394,7 +3395,7 @@
               <a:buChar char="•"/>
             </a:pPr>
             <a:r>
-              <a:rPr lang="en-US" sz="1100" dirty="0">
+              <a:rPr lang="en-US" sz="1000" dirty="0">
                 <a:solidFill>
                   <a:srgbClr val="D0D8F0"/>
                 </a:solidFill>
@@ -3415,7 +3416,7 @@
               <a:buChar char="•"/>
             </a:pPr>
             <a:r>
-              <a:rPr lang="en-US" sz="1100" dirty="0">
+              <a:rPr lang="en-US" sz="1000" dirty="0">
                 <a:solidFill>
                   <a:srgbClr val="D0D8F0"/>
                 </a:solidFill>
@@ -3436,7 +3437,7 @@
               <a:buChar char="•"/>
             </a:pPr>
             <a:r>
-              <a:rPr lang="en-US" sz="1100" dirty="0">
+              <a:rPr lang="en-US" sz="1000" dirty="0">
                 <a:solidFill>
                   <a:srgbClr val="D0D8F0"/>
                 </a:solidFill>
@@ -3459,7 +3460,7 @@
         <p:spPr>
           <a:xfrm>
             <a:off x="4892040" y="2011680"/>
-            <a:ext cx="3931920" cy="2377440"/>
+            <a:ext cx="3931920" cy="2468880"/>
           </a:xfrm>
           <a:prstGeom prst="rect">
             <a:avLst/>
@@ -3840,6 +3841,729 @@
               <a:t>4-Week Client Engagement  ·  Siena Heights University PDC  ·  MBB Senseis: Dr. Ben Benson &amp; Mr. Phil White  ·  Q2 2024</a:t>
             </a:r>
             <a:endParaRPr lang="en-US" sz="950" dirty="0"/>
+          </a:p>
+        </p:txBody>
+      </p:sp>
+    </p:spTree>
+  </p:cSld>
+  <p:clrMapOvr>
+    <a:masterClrMapping/>
+  </p:clrMapOvr>
+</p:sld>
+</file>
+
+<file path=ppt/slides/slide12.xml><?xml version="1.0" encoding="utf-8"?>
+<p:sld xmlns:a="http://schemas.openxmlformats.org/drawingml/2006/main" xmlns:r="http://schemas.openxmlformats.org/officeDocument/2006/relationships" xmlns:p="http://schemas.openxmlformats.org/presentationml/2006/main">
+  <p:cSld name="Slide 10">
+    <p:bg>
+      <p:bgPr>
+        <a:solidFill>
+          <a:srgbClr val="F4F7FF"/>
+        </a:solidFill>
+      </p:bgPr>
+    </p:bg>
+    <p:spTree>
+      <p:nvGrpSpPr>
+        <p:cNvPr id="1" name=""/>
+        <p:cNvGrpSpPr/>
+        <p:nvPr/>
+      </p:nvGrpSpPr>
+      <p:grpSpPr>
+        <a:xfrm>
+          <a:off x="0" y="0"/>
+          <a:ext cx="0" cy="0"/>
+          <a:chOff x="0" y="0"/>
+          <a:chExt cx="0" cy="0"/>
+        </a:xfrm>
+      </p:grpSpPr>
+      <p:sp>
+        <p:nvSpPr>
+          <p:cNvPr id="2" name="Shape 0"/>
+          <p:cNvSpPr/>
+          <p:nvPr/>
+        </p:nvSpPr>
+        <p:spPr>
+          <a:xfrm>
+            <a:off x="0" y="0"/>
+            <a:ext cx="9144000" cy="777240"/>
+          </a:xfrm>
+          <a:prstGeom prst="rect">
+            <a:avLst/>
+          </a:prstGeom>
+          <a:solidFill>
+            <a:srgbClr val="1E2761"/>
+          </a:solidFill>
+          <a:ln w="12700">
+            <a:solidFill>
+              <a:srgbClr val="1E2761"/>
+            </a:solidFill>
+            <a:prstDash val="solid"/>
+          </a:ln>
+        </p:spPr>
+      </p:sp>
+      <p:sp>
+        <p:nvSpPr>
+          <p:cNvPr id="3" name="Text 1"/>
+          <p:cNvSpPr/>
+          <p:nvPr/>
+        </p:nvSpPr>
+        <p:spPr>
+          <a:xfrm>
+            <a:off x="365760" y="0"/>
+            <a:ext cx="8229600" cy="777240"/>
+          </a:xfrm>
+          <a:prstGeom prst="rect">
+            <a:avLst/>
+          </a:prstGeom>
+          <a:noFill/>
+          <a:ln/>
+        </p:spPr>
+        <p:txBody>
+          <a:bodyPr wrap="square" lIns="0" tIns="0" rIns="0" bIns="0" rtlCol="0" anchor="ctr"/>
+          <a:lstStyle/>
+          <a:p>
+            <a:pPr indent="0" marL="0">
+              <a:buNone/>
+            </a:pPr>
+            <a:r>
+              <a:rPr lang="en-US" sz="1400" b="1" spc="200" kern="0" dirty="0">
+                <a:solidFill>
+                  <a:srgbClr val="FFFFFF"/>
+                </a:solidFill>
+                <a:latin typeface="Calibri" pitchFamily="34" charset="0"/>
+                <a:ea typeface="Calibri" pitchFamily="34" charset="-122"/>
+                <a:cs typeface="Calibri" pitchFamily="34" charset="-120"/>
+              </a:rPr>
+              <a:t>LESSONS LEARNED  ·  Running the Engagement</a:t>
+            </a:r>
+            <a:endParaRPr lang="en-US" sz="1400" dirty="0"/>
+          </a:p>
+        </p:txBody>
+      </p:sp>
+      <p:sp>
+        <p:nvSpPr>
+          <p:cNvPr id="4" name="Shape 2"/>
+          <p:cNvSpPr/>
+          <p:nvPr/>
+        </p:nvSpPr>
+        <p:spPr>
+          <a:xfrm>
+            <a:off x="274320" y="960120"/>
+            <a:ext cx="2697480" cy="3886200"/>
+          </a:xfrm>
+          <a:prstGeom prst="rect">
+            <a:avLst/>
+          </a:prstGeom>
+          <a:solidFill>
+            <a:srgbClr val="FFFFFF"/>
+          </a:solidFill>
+          <a:ln w="12700">
+            <a:solidFill>
+              <a:srgbClr val="E2E8F0"/>
+            </a:solidFill>
+            <a:prstDash val="solid"/>
+          </a:ln>
+          <a:effectLst>
+            <a:outerShdw sx="100000" sy="100000" kx="0" ky="0" algn="bl" rotWithShape="0" blurRad="101600" dist="38100" dir="8100000">
+              <a:srgbClr val="000000">
+                <a:alpha val="10000"/>
+              </a:srgbClr>
+            </a:outerShdw>
+          </a:effectLst>
+        </p:spPr>
+      </p:sp>
+      <p:sp>
+        <p:nvSpPr>
+          <p:cNvPr id="5" name="Shape 3"/>
+          <p:cNvSpPr/>
+          <p:nvPr/>
+        </p:nvSpPr>
+        <p:spPr>
+          <a:xfrm>
+            <a:off x="274320" y="960120"/>
+            <a:ext cx="2697480" cy="457200"/>
+          </a:xfrm>
+          <a:prstGeom prst="rect">
+            <a:avLst/>
+          </a:prstGeom>
+          <a:solidFill>
+            <a:srgbClr val="1E2761"/>
+          </a:solidFill>
+          <a:ln w="12700">
+            <a:solidFill>
+              <a:srgbClr val="1E2761"/>
+            </a:solidFill>
+            <a:prstDash val="solid"/>
+          </a:ln>
+        </p:spPr>
+      </p:sp>
+      <p:sp>
+        <p:nvSpPr>
+          <p:cNvPr id="6" name="Text 4"/>
+          <p:cNvSpPr/>
+          <p:nvPr/>
+        </p:nvSpPr>
+        <p:spPr>
+          <a:xfrm>
+            <a:off x="384048" y="960120"/>
+            <a:ext cx="2478024" cy="457200"/>
+          </a:xfrm>
+          <a:prstGeom prst="rect">
+            <a:avLst/>
+          </a:prstGeom>
+          <a:noFill/>
+          <a:ln/>
+        </p:spPr>
+        <p:txBody>
+          <a:bodyPr wrap="square" lIns="0" tIns="0" rIns="0" bIns="0" rtlCol="0" anchor="ctr"/>
+          <a:lstStyle/>
+          <a:p>
+            <a:pPr indent="0" marL="0">
+              <a:buNone/>
+            </a:pPr>
+            <a:r>
+              <a:rPr lang="en-US" sz="1100" b="1" dirty="0">
+                <a:solidFill>
+                  <a:srgbClr val="FFFFFF"/>
+                </a:solidFill>
+                <a:latin typeface="Calibri" pitchFamily="34" charset="0"/>
+                <a:ea typeface="Calibri" pitchFamily="34" charset="-122"/>
+                <a:cs typeface="Calibri" pitchFamily="34" charset="-120"/>
+              </a:rPr>
+              <a:t>What Went Well</a:t>
+            </a:r>
+            <a:endParaRPr lang="en-US" sz="1100" dirty="0"/>
+          </a:p>
+        </p:txBody>
+      </p:sp>
+      <p:sp>
+        <p:nvSpPr>
+          <p:cNvPr id="7" name="Text 5"/>
+          <p:cNvSpPr/>
+          <p:nvPr/>
+        </p:nvSpPr>
+        <p:spPr>
+          <a:xfrm>
+            <a:off x="411480" y="1508760"/>
+            <a:ext cx="2423160" cy="3200400"/>
+          </a:xfrm>
+          <a:prstGeom prst="rect">
+            <a:avLst/>
+          </a:prstGeom>
+          <a:noFill/>
+          <a:ln/>
+        </p:spPr>
+        <p:txBody>
+          <a:bodyPr wrap="square" lIns="0" tIns="0" rIns="0" bIns="0" rtlCol="0" anchor="t"/>
+          <a:lstStyle/>
+          <a:p>
+            <a:pPr marL="342900" indent="-342900">
+              <a:spcAft>
+                <a:spcPts val="500"/>
+              </a:spcAft>
+              <a:buSzPct val="100000"/>
+              <a:buChar char="•"/>
+            </a:pPr>
+            <a:r>
+              <a:rPr lang="en-US" sz="1150" dirty="0">
+                <a:solidFill>
+                  <a:srgbClr val="1A1A2E"/>
+                </a:solidFill>
+                <a:latin typeface="Calibri" pitchFamily="34" charset="0"/>
+                <a:ea typeface="Calibri" pitchFamily="34" charset="-122"/>
+                <a:cs typeface="Calibri" pitchFamily="34" charset="-120"/>
+              </a:rPr>
+              <a:t>Director-level sponsorship (Mr. Antonis) from day one kept a 4-week, 12-lab engagement on schedule</a:t>
+            </a:r>
+            <a:endParaRPr lang="en-US" sz="1150" dirty="0"/>
+          </a:p>
+          <a:p>
+            <a:pPr marL="342900" indent="-342900">
+              <a:spcAft>
+                <a:spcPts val="500"/>
+              </a:spcAft>
+              <a:buSzPct val="100000"/>
+              <a:buChar char="•"/>
+            </a:pPr>
+            <a:r>
+              <a:rPr lang="en-US" sz="1150" dirty="0">
+                <a:solidFill>
+                  <a:srgbClr val="1A1A2E"/>
+                </a:solidFill>
+                <a:latin typeface="Calibri" pitchFamily="34" charset="0"/>
+                <a:ea typeface="Calibri" pitchFamily="34" charset="-122"/>
+                <a:cs typeface="Calibri" pitchFamily="34" charset="-120"/>
+              </a:rPr>
+              <a:t>Pairing 180+ field observations with direct interviews surfaced the Lab 5 outlier pattern faster than data alone</a:t>
+            </a:r>
+            <a:endParaRPr lang="en-US" sz="1150" dirty="0"/>
+          </a:p>
+          <a:p>
+            <a:pPr marL="342900" indent="-342900">
+              <a:spcAft>
+                <a:spcPts val="500"/>
+              </a:spcAft>
+              <a:buSzPct val="100000"/>
+              <a:buChar char="•"/>
+            </a:pPr>
+            <a:r>
+              <a:rPr lang="en-US" sz="1150" dirty="0">
+                <a:solidFill>
+                  <a:srgbClr val="1A1A2E"/>
+                </a:solidFill>
+                <a:latin typeface="Calibri" pitchFamily="34" charset="0"/>
+                <a:ea typeface="Calibri" pitchFamily="34" charset="-122"/>
+                <a:cs typeface="Calibri" pitchFamily="34" charset="-120"/>
+              </a:rPr>
+              <a:t>Validating the process change on 3 pilot labs with a two-sample T-test gave leadership a statistically defensible go/no-go</a:t>
+            </a:r>
+            <a:endParaRPr lang="en-US" sz="1150" dirty="0"/>
+          </a:p>
+          <a:p>
+            <a:pPr marL="342900" indent="-342900">
+              <a:spcAft>
+                <a:spcPts val="500"/>
+              </a:spcAft>
+              <a:buSzPct val="100000"/>
+              <a:buChar char="•"/>
+            </a:pPr>
+            <a:r>
+              <a:rPr lang="en-US" sz="1150" dirty="0">
+                <a:solidFill>
+                  <a:srgbClr val="1A1A2E"/>
+                </a:solidFill>
+                <a:latin typeface="Calibri" pitchFamily="34" charset="0"/>
+                <a:ea typeface="Calibri" pitchFamily="34" charset="-122"/>
+                <a:cs typeface="Calibri" pitchFamily="34" charset="-120"/>
+              </a:rPr>
+              <a:t>Findings presented directly to the Director of Laboratory Services kept executive sponsorship engaged through rollout</a:t>
+            </a:r>
+            <a:endParaRPr lang="en-US" sz="1150" dirty="0"/>
+          </a:p>
+        </p:txBody>
+      </p:sp>
+      <p:sp>
+        <p:nvSpPr>
+          <p:cNvPr id="8" name="Shape 6"/>
+          <p:cNvSpPr/>
+          <p:nvPr/>
+        </p:nvSpPr>
+        <p:spPr>
+          <a:xfrm>
+            <a:off x="3172968" y="960120"/>
+            <a:ext cx="2697480" cy="3886200"/>
+          </a:xfrm>
+          <a:prstGeom prst="rect">
+            <a:avLst/>
+          </a:prstGeom>
+          <a:solidFill>
+            <a:srgbClr val="FFFFFF"/>
+          </a:solidFill>
+          <a:ln w="12700">
+            <a:solidFill>
+              <a:srgbClr val="E2E8F0"/>
+            </a:solidFill>
+            <a:prstDash val="solid"/>
+          </a:ln>
+          <a:effectLst>
+            <a:outerShdw sx="100000" sy="100000" kx="0" ky="0" algn="bl" rotWithShape="0" blurRad="101600" dist="38100" dir="8100000">
+              <a:srgbClr val="000000">
+                <a:alpha val="10000"/>
+              </a:srgbClr>
+            </a:outerShdw>
+          </a:effectLst>
+        </p:spPr>
+      </p:sp>
+      <p:sp>
+        <p:nvSpPr>
+          <p:cNvPr id="9" name="Shape 7"/>
+          <p:cNvSpPr/>
+          <p:nvPr/>
+        </p:nvSpPr>
+        <p:spPr>
+          <a:xfrm>
+            <a:off x="3172968" y="960120"/>
+            <a:ext cx="2697480" cy="457200"/>
+          </a:xfrm>
+          <a:prstGeom prst="rect">
+            <a:avLst/>
+          </a:prstGeom>
+          <a:solidFill>
+            <a:srgbClr val="0284C7"/>
+          </a:solidFill>
+          <a:ln w="12700">
+            <a:solidFill>
+              <a:srgbClr val="0284C7"/>
+            </a:solidFill>
+            <a:prstDash val="solid"/>
+          </a:ln>
+        </p:spPr>
+      </p:sp>
+      <p:sp>
+        <p:nvSpPr>
+          <p:cNvPr id="10" name="Text 8"/>
+          <p:cNvSpPr/>
+          <p:nvPr/>
+        </p:nvSpPr>
+        <p:spPr>
+          <a:xfrm>
+            <a:off x="3282696" y="960120"/>
+            <a:ext cx="2478024" cy="457200"/>
+          </a:xfrm>
+          <a:prstGeom prst="rect">
+            <a:avLst/>
+          </a:prstGeom>
+          <a:noFill/>
+          <a:ln/>
+        </p:spPr>
+        <p:txBody>
+          <a:bodyPr wrap="square" lIns="0" tIns="0" rIns="0" bIns="0" rtlCol="0" anchor="ctr"/>
+          <a:lstStyle/>
+          <a:p>
+            <a:pPr indent="0" marL="0">
+              <a:buNone/>
+            </a:pPr>
+            <a:r>
+              <a:rPr lang="en-US" sz="1100" b="1" dirty="0">
+                <a:solidFill>
+                  <a:srgbClr val="FFFFFF"/>
+                </a:solidFill>
+                <a:latin typeface="Calibri" pitchFamily="34" charset="0"/>
+                <a:ea typeface="Calibri" pitchFamily="34" charset="-122"/>
+                <a:cs typeface="Calibri" pitchFamily="34" charset="-120"/>
+              </a:rPr>
+              <a:t>Key Takeaways</a:t>
+            </a:r>
+            <a:endParaRPr lang="en-US" sz="1100" dirty="0"/>
+          </a:p>
+        </p:txBody>
+      </p:sp>
+      <p:sp>
+        <p:nvSpPr>
+          <p:cNvPr id="11" name="Text 9"/>
+          <p:cNvSpPr/>
+          <p:nvPr/>
+        </p:nvSpPr>
+        <p:spPr>
+          <a:xfrm>
+            <a:off x="3310128" y="1508760"/>
+            <a:ext cx="2423160" cy="3200400"/>
+          </a:xfrm>
+          <a:prstGeom prst="rect">
+            <a:avLst/>
+          </a:prstGeom>
+          <a:noFill/>
+          <a:ln/>
+        </p:spPr>
+        <p:txBody>
+          <a:bodyPr wrap="square" lIns="0" tIns="0" rIns="0" bIns="0" rtlCol="0" anchor="t"/>
+          <a:lstStyle/>
+          <a:p>
+            <a:pPr marL="342900" indent="-342900">
+              <a:spcAft>
+                <a:spcPts val="500"/>
+              </a:spcAft>
+              <a:buSzPct val="100000"/>
+              <a:buChar char="•"/>
+            </a:pPr>
+            <a:r>
+              <a:rPr lang="en-US" sz="1150" dirty="0">
+                <a:solidFill>
+                  <a:srgbClr val="1A1A2E"/>
+                </a:solidFill>
+                <a:latin typeface="Calibri" pitchFamily="34" charset="0"/>
+                <a:ea typeface="Calibri" pitchFamily="34" charset="-122"/>
+                <a:cs typeface="Calibri" pitchFamily="34" charset="-120"/>
+              </a:rPr>
+              <a:t>Pilot-before-scale is worth defaulting to on any multi-site rollout, not only when time allows</a:t>
+            </a:r>
+            <a:endParaRPr lang="en-US" sz="1150" dirty="0"/>
+          </a:p>
+          <a:p>
+            <a:pPr marL="342900" indent="-342900">
+              <a:spcAft>
+                <a:spcPts val="500"/>
+              </a:spcAft>
+              <a:buSzPct val="100000"/>
+              <a:buChar char="•"/>
+            </a:pPr>
+            <a:r>
+              <a:rPr lang="en-US" sz="1150" dirty="0">
+                <a:solidFill>
+                  <a:srgbClr val="1A1A2E"/>
+                </a:solidFill>
+                <a:latin typeface="Calibri" pitchFamily="34" charset="0"/>
+                <a:ea typeface="Calibri" pitchFamily="34" charset="-122"/>
+                <a:cs typeface="Calibri" pitchFamily="34" charset="-120"/>
+              </a:rPr>
+              <a:t>Frontline interviews belong in Define, not as a supplement added after baseline data collection</a:t>
+            </a:r>
+            <a:endParaRPr lang="en-US" sz="1150" dirty="0"/>
+          </a:p>
+          <a:p>
+            <a:pPr marL="342900" indent="-342900">
+              <a:spcAft>
+                <a:spcPts val="500"/>
+              </a:spcAft>
+              <a:buSzPct val="100000"/>
+              <a:buChar char="•"/>
+            </a:pPr>
+            <a:r>
+              <a:rPr lang="en-US" sz="1150" dirty="0">
+                <a:solidFill>
+                  <a:srgbClr val="1A1A2E"/>
+                </a:solidFill>
+                <a:latin typeface="Calibri" pitchFamily="34" charset="0"/>
+                <a:ea typeface="Calibri" pitchFamily="34" charset="-122"/>
+                <a:cs typeface="Calibri" pitchFamily="34" charset="-120"/>
+              </a:rPr>
+              <a:t>A sustainment plan is only as strong as the adherence check built into its charter</a:t>
+            </a:r>
+            <a:endParaRPr lang="en-US" sz="1150" dirty="0"/>
+          </a:p>
+          <a:p>
+            <a:pPr marL="342900" indent="-342900">
+              <a:spcAft>
+                <a:spcPts val="500"/>
+              </a:spcAft>
+              <a:buSzPct val="100000"/>
+              <a:buChar char="•"/>
+            </a:pPr>
+            <a:r>
+              <a:rPr lang="en-US" sz="1150" dirty="0">
+                <a:solidFill>
+                  <a:srgbClr val="1A1A2E"/>
+                </a:solidFill>
+                <a:latin typeface="Calibri" pitchFamily="34" charset="0"/>
+                <a:ea typeface="Calibri" pitchFamily="34" charset="-122"/>
+                <a:cs typeface="Calibri" pitchFamily="34" charset="-120"/>
+              </a:rPr>
+              <a:t>Statistical validation turns a process recommendation into a leadership decision, not just an analyst's opinion</a:t>
+            </a:r>
+            <a:endParaRPr lang="en-US" sz="1150" dirty="0"/>
+          </a:p>
+        </p:txBody>
+      </p:sp>
+      <p:sp>
+        <p:nvSpPr>
+          <p:cNvPr id="12" name="Shape 10"/>
+          <p:cNvSpPr/>
+          <p:nvPr/>
+        </p:nvSpPr>
+        <p:spPr>
+          <a:xfrm>
+            <a:off x="6071616" y="960120"/>
+            <a:ext cx="2697480" cy="3886200"/>
+          </a:xfrm>
+          <a:prstGeom prst="rect">
+            <a:avLst/>
+          </a:prstGeom>
+          <a:solidFill>
+            <a:srgbClr val="FFFFFF"/>
+          </a:solidFill>
+          <a:ln w="12700">
+            <a:solidFill>
+              <a:srgbClr val="E2E8F0"/>
+            </a:solidFill>
+            <a:prstDash val="solid"/>
+          </a:ln>
+          <a:effectLst>
+            <a:outerShdw sx="100000" sy="100000" kx="0" ky="0" algn="bl" rotWithShape="0" blurRad="101600" dist="38100" dir="8100000">
+              <a:srgbClr val="000000">
+                <a:alpha val="10000"/>
+              </a:srgbClr>
+            </a:outerShdw>
+          </a:effectLst>
+        </p:spPr>
+      </p:sp>
+      <p:sp>
+        <p:nvSpPr>
+          <p:cNvPr id="13" name="Shape 11"/>
+          <p:cNvSpPr/>
+          <p:nvPr/>
+        </p:nvSpPr>
+        <p:spPr>
+          <a:xfrm>
+            <a:off x="6071616" y="960120"/>
+            <a:ext cx="2697480" cy="457200"/>
+          </a:xfrm>
+          <a:prstGeom prst="rect">
+            <a:avLst/>
+          </a:prstGeom>
+          <a:solidFill>
+            <a:srgbClr val="047857"/>
+          </a:solidFill>
+          <a:ln w="12700">
+            <a:solidFill>
+              <a:srgbClr val="047857"/>
+            </a:solidFill>
+            <a:prstDash val="solid"/>
+          </a:ln>
+        </p:spPr>
+      </p:sp>
+      <p:sp>
+        <p:nvSpPr>
+          <p:cNvPr id="14" name="Text 12"/>
+          <p:cNvSpPr/>
+          <p:nvPr/>
+        </p:nvSpPr>
+        <p:spPr>
+          <a:xfrm>
+            <a:off x="6181344" y="960120"/>
+            <a:ext cx="2478024" cy="457200"/>
+          </a:xfrm>
+          <a:prstGeom prst="rect">
+            <a:avLst/>
+          </a:prstGeom>
+          <a:noFill/>
+          <a:ln/>
+        </p:spPr>
+        <p:txBody>
+          <a:bodyPr wrap="square" lIns="0" tIns="0" rIns="0" bIns="0" rtlCol="0" anchor="ctr"/>
+          <a:lstStyle/>
+          <a:p>
+            <a:pPr indent="0" marL="0">
+              <a:buNone/>
+            </a:pPr>
+            <a:r>
+              <a:rPr lang="en-US" sz="1100" b="1" dirty="0">
+                <a:solidFill>
+                  <a:srgbClr val="FFFFFF"/>
+                </a:solidFill>
+                <a:latin typeface="Calibri" pitchFamily="34" charset="0"/>
+                <a:ea typeface="Calibri" pitchFamily="34" charset="-122"/>
+                <a:cs typeface="Calibri" pitchFamily="34" charset="-120"/>
+              </a:rPr>
+              <a:t>Carried Into Future Engagements</a:t>
+            </a:r>
+            <a:endParaRPr lang="en-US" sz="1100" dirty="0"/>
+          </a:p>
+        </p:txBody>
+      </p:sp>
+      <p:sp>
+        <p:nvSpPr>
+          <p:cNvPr id="15" name="Text 13"/>
+          <p:cNvSpPr/>
+          <p:nvPr/>
+        </p:nvSpPr>
+        <p:spPr>
+          <a:xfrm>
+            <a:off x="6208776" y="1508760"/>
+            <a:ext cx="2423160" cy="3200400"/>
+          </a:xfrm>
+          <a:prstGeom prst="rect">
+            <a:avLst/>
+          </a:prstGeom>
+          <a:noFill/>
+          <a:ln/>
+        </p:spPr>
+        <p:txBody>
+          <a:bodyPr wrap="square" lIns="0" tIns="0" rIns="0" bIns="0" rtlCol="0" anchor="t"/>
+          <a:lstStyle/>
+          <a:p>
+            <a:pPr marL="342900" indent="-342900">
+              <a:spcAft>
+                <a:spcPts val="500"/>
+              </a:spcAft>
+              <a:buSzPct val="100000"/>
+              <a:buChar char="•"/>
+            </a:pPr>
+            <a:r>
+              <a:rPr lang="en-US" sz="1150" dirty="0">
+                <a:solidFill>
+                  <a:srgbClr val="1A1A2E"/>
+                </a:solidFill>
+                <a:latin typeface="Calibri" pitchFamily="34" charset="0"/>
+                <a:ea typeface="Calibri" pitchFamily="34" charset="-122"/>
+                <a:cs typeface="Calibri" pitchFamily="34" charset="-120"/>
+              </a:rPr>
+              <a:t>Build a 30/60/90-day adherence checkpoint into every Control plan charter up front</a:t>
+            </a:r>
+            <a:endParaRPr lang="en-US" sz="1150" dirty="0"/>
+          </a:p>
+          <a:p>
+            <a:pPr marL="342900" indent="-342900">
+              <a:spcAft>
+                <a:spcPts val="500"/>
+              </a:spcAft>
+              <a:buSzPct val="100000"/>
+              <a:buChar char="•"/>
+            </a:pPr>
+            <a:r>
+              <a:rPr lang="en-US" sz="1150" dirty="0">
+                <a:solidFill>
+                  <a:srgbClr val="1A1A2E"/>
+                </a:solidFill>
+                <a:latin typeface="Calibri" pitchFamily="34" charset="0"/>
+                <a:ea typeface="Calibri" pitchFamily="34" charset="-122"/>
+                <a:cs typeface="Calibri" pitchFamily="34" charset="-120"/>
+              </a:rPr>
+              <a:t>Default to a reference-site pilot before any enterprise-wide standard-work rollout</a:t>
+            </a:r>
+            <a:endParaRPr lang="en-US" sz="1150" dirty="0"/>
+          </a:p>
+          <a:p>
+            <a:pPr marL="342900" indent="-342900">
+              <a:spcAft>
+                <a:spcPts val="500"/>
+              </a:spcAft>
+              <a:buSzPct val="100000"/>
+              <a:buChar char="•"/>
+            </a:pPr>
+            <a:r>
+              <a:rPr lang="en-US" sz="1150" dirty="0">
+                <a:solidFill>
+                  <a:srgbClr val="1A1A2E"/>
+                </a:solidFill>
+                <a:latin typeface="Calibri" pitchFamily="34" charset="0"/>
+                <a:ea typeface="Calibri" pitchFamily="34" charset="-122"/>
+                <a:cs typeface="Calibri" pitchFamily="34" charset="-120"/>
+              </a:rPr>
+              <a:t>Pair quantitative baseline data with frontline interviews from the start, not sequentially</a:t>
+            </a:r>
+            <a:endParaRPr lang="en-US" sz="1150" dirty="0"/>
+          </a:p>
+          <a:p>
+            <a:pPr marL="342900" indent="-342900">
+              <a:spcAft>
+                <a:spcPts val="500"/>
+              </a:spcAft>
+              <a:buSzPct val="100000"/>
+              <a:buChar char="•"/>
+            </a:pPr>
+            <a:r>
+              <a:rPr lang="en-US" sz="1150" dirty="0">
+                <a:solidFill>
+                  <a:srgbClr val="1A1A2E"/>
+                </a:solidFill>
+                <a:latin typeface="Calibri" pitchFamily="34" charset="0"/>
+                <a:ea typeface="Calibri" pitchFamily="34" charset="-122"/>
+                <a:cs typeface="Calibri" pitchFamily="34" charset="-120"/>
+              </a:rPr>
+              <a:t>Treat statistical validation as a standard deliverable for any before/after process claim</a:t>
+            </a:r>
+            <a:endParaRPr lang="en-US" sz="1150" dirty="0"/>
+          </a:p>
+          <a:p>
+            <a:pPr marL="342900" indent="-342900">
+              <a:spcAft>
+                <a:spcPts val="500"/>
+              </a:spcAft>
+              <a:buSzPct val="100000"/>
+              <a:buChar char="•"/>
+            </a:pPr>
+            <a:r>
+              <a:rPr lang="en-US" sz="1150" dirty="0">
+                <a:solidFill>
+                  <a:srgbClr val="1A1A2E"/>
+                </a:solidFill>
+                <a:latin typeface="Calibri" pitchFamily="34" charset="0"/>
+                <a:ea typeface="Calibri" pitchFamily="34" charset="-122"/>
+                <a:cs typeface="Calibri" pitchFamily="34" charset="-120"/>
+              </a:rPr>
+              <a:t>Keep executive sponsorship visible through implementation, not just at kickoff</a:t>
+            </a:r>
+            <a:endParaRPr lang="en-US" sz="1150" dirty="0"/>
           </a:p>
         </p:txBody>
       </p:sp>

</xml_diff>